<commit_message>
29 Oct 2026 (Thu), 12:23 AM
</commit_message>
<xml_diff>
--- a/Python-B04-Allyster Endozo.pptx
+++ b/Python-B04-Allyster Endozo.pptx
@@ -21,15 +21,18 @@
     <p:sldId id="272" r:id="rId15"/>
     <p:sldId id="262" r:id="rId16"/>
     <p:sldId id="273" r:id="rId17"/>
-    <p:sldId id="264" r:id="rId18"/>
-    <p:sldId id="266" r:id="rId19"/>
-    <p:sldId id="265" r:id="rId20"/>
-    <p:sldId id="274" r:id="rId21"/>
-    <p:sldId id="275" r:id="rId22"/>
-    <p:sldId id="277" r:id="rId23"/>
-    <p:sldId id="279" r:id="rId24"/>
-    <p:sldId id="281" r:id="rId25"/>
-    <p:sldId id="278" r:id="rId26"/>
+    <p:sldId id="284" r:id="rId18"/>
+    <p:sldId id="285" r:id="rId19"/>
+    <p:sldId id="283" r:id="rId20"/>
+    <p:sldId id="264" r:id="rId21"/>
+    <p:sldId id="266" r:id="rId22"/>
+    <p:sldId id="265" r:id="rId23"/>
+    <p:sldId id="274" r:id="rId24"/>
+    <p:sldId id="275" r:id="rId25"/>
+    <p:sldId id="277" r:id="rId26"/>
+    <p:sldId id="279" r:id="rId27"/>
+    <p:sldId id="281" r:id="rId28"/>
+    <p:sldId id="278" r:id="rId29"/>
   </p:sldIdLst>
   <p:sldSz cx="12192000" cy="6858000"/>
   <p:notesSz cx="6858000" cy="9144000"/>
@@ -128,6 +131,11 @@
       </a:defRPr>
     </a:lvl9pPr>
   </p:defaultTextStyle>
+  <p:extLst>
+    <p:ext uri="{EFAFB233-063F-42B5-8137-9DF3F51BA10A}">
+      <p15:sldGuideLst xmlns:p15="http://schemas.microsoft.com/office/powerpoint/2012/main"/>
+    </p:ext>
+  </p:extLst>
 </p:presentation>
 </file>
 
@@ -278,7 +286,7 @@
           <a:p>
             <a:fld id="{995067D5-EC1A-4409-8F8E-A7A83362B671}" type="datetimeFigureOut">
               <a:rPr lang="en-US" smtClean="0"/>
-              <a:t>10/28/2026</a:t>
+              <a:t>10/29/2026</a:t>
             </a:fld>
             <a:endParaRPr lang="en-US"/>
           </a:p>
@@ -476,7 +484,7 @@
           <a:p>
             <a:fld id="{995067D5-EC1A-4409-8F8E-A7A83362B671}" type="datetimeFigureOut">
               <a:rPr lang="en-US" smtClean="0"/>
-              <a:t>10/28/2026</a:t>
+              <a:t>10/29/2026</a:t>
             </a:fld>
             <a:endParaRPr lang="en-US"/>
           </a:p>
@@ -684,7 +692,7 @@
           <a:p>
             <a:fld id="{995067D5-EC1A-4409-8F8E-A7A83362B671}" type="datetimeFigureOut">
               <a:rPr lang="en-US" smtClean="0"/>
-              <a:t>10/28/2026</a:t>
+              <a:t>10/29/2026</a:t>
             </a:fld>
             <a:endParaRPr lang="en-US"/>
           </a:p>
@@ -1157,7 +1165,7 @@
           <a:p>
             <a:fld id="{995067D5-EC1A-4409-8F8E-A7A83362B671}" type="datetimeFigureOut">
               <a:rPr lang="en-US" smtClean="0"/>
-              <a:t>10/28/2026</a:t>
+              <a:t>10/29/2026</a:t>
             </a:fld>
             <a:endParaRPr lang="en-US"/>
           </a:p>
@@ -1422,7 +1430,7 @@
           <a:p>
             <a:fld id="{995067D5-EC1A-4409-8F8E-A7A83362B671}" type="datetimeFigureOut">
               <a:rPr lang="en-US" smtClean="0"/>
-              <a:t>10/28/2026</a:t>
+              <a:t>10/29/2026</a:t>
             </a:fld>
             <a:endParaRPr lang="en-US"/>
           </a:p>
@@ -1834,7 +1842,7 @@
           <a:p>
             <a:fld id="{995067D5-EC1A-4409-8F8E-A7A83362B671}" type="datetimeFigureOut">
               <a:rPr lang="en-US" smtClean="0"/>
-              <a:t>10/28/2026</a:t>
+              <a:t>10/29/2026</a:t>
             </a:fld>
             <a:endParaRPr lang="en-US"/>
           </a:p>
@@ -1975,7 +1983,7 @@
           <a:p>
             <a:fld id="{995067D5-EC1A-4409-8F8E-A7A83362B671}" type="datetimeFigureOut">
               <a:rPr lang="en-US" smtClean="0"/>
-              <a:t>10/28/2026</a:t>
+              <a:t>10/29/2026</a:t>
             </a:fld>
             <a:endParaRPr lang="en-US"/>
           </a:p>
@@ -2088,7 +2096,7 @@
           <a:p>
             <a:fld id="{995067D5-EC1A-4409-8F8E-A7A83362B671}" type="datetimeFigureOut">
               <a:rPr lang="en-US" smtClean="0"/>
-              <a:t>10/28/2026</a:t>
+              <a:t>10/29/2026</a:t>
             </a:fld>
             <a:endParaRPr lang="en-US"/>
           </a:p>
@@ -2399,7 +2407,7 @@
           <a:p>
             <a:fld id="{995067D5-EC1A-4409-8F8E-A7A83362B671}" type="datetimeFigureOut">
               <a:rPr lang="en-US" smtClean="0"/>
-              <a:t>10/28/2026</a:t>
+              <a:t>10/29/2026</a:t>
             </a:fld>
             <a:endParaRPr lang="en-US"/>
           </a:p>
@@ -2687,7 +2695,7 @@
           <a:p>
             <a:fld id="{995067D5-EC1A-4409-8F8E-A7A83362B671}" type="datetimeFigureOut">
               <a:rPr lang="en-US" smtClean="0"/>
-              <a:t>10/28/2026</a:t>
+              <a:t>10/29/2026</a:t>
             </a:fld>
             <a:endParaRPr lang="en-US"/>
           </a:p>
@@ -4037,6 +4045,451 @@
   <p:cSld>
     <p:spTree>
       <p:nvGrpSpPr>
+        <p:cNvPr id="1" name="">
+          <a:extLst>
+            <a:ext uri="{FF2B5EF4-FFF2-40B4-BE49-F238E27FC236}">
+              <a16:creationId xmlns:a16="http://schemas.microsoft.com/office/drawing/2014/main" id="{6824973B-0D68-F59E-AD2F-0209C4AD29C4}"/>
+            </a:ext>
+          </a:extLst>
+        </p:cNvPr>
+        <p:cNvGrpSpPr/>
+        <p:nvPr/>
+      </p:nvGrpSpPr>
+      <p:grpSpPr>
+        <a:xfrm>
+          <a:off x="0" y="0"/>
+          <a:ext cx="0" cy="0"/>
+          <a:chOff x="0" y="0"/>
+          <a:chExt cx="0" cy="0"/>
+        </a:xfrm>
+      </p:grpSpPr>
+      <p:sp>
+        <p:nvSpPr>
+          <p:cNvPr id="2" name="Title 1">
+            <a:extLst>
+              <a:ext uri="{FF2B5EF4-FFF2-40B4-BE49-F238E27FC236}">
+                <a16:creationId xmlns:a16="http://schemas.microsoft.com/office/drawing/2014/main" id="{D3EA979B-8FC1-7453-143D-D0DA320C2177}"/>
+              </a:ext>
+            </a:extLst>
+          </p:cNvPr>
+          <p:cNvSpPr>
+            <a:spLocks noGrp="1"/>
+          </p:cNvSpPr>
+          <p:nvPr>
+            <p:ph type="title"/>
+          </p:nvPr>
+        </p:nvSpPr>
+        <p:spPr/>
+        <p:txBody>
+          <a:bodyPr/>
+          <a:lstStyle/>
+          <a:p>
+            <a:r>
+              <a:rPr lang="en-PH" dirty="0"/>
+              <a:t>Summary and Conclusions</a:t>
+            </a:r>
+            <a:endParaRPr lang="en-US" dirty="0"/>
+          </a:p>
+        </p:txBody>
+      </p:sp>
+      <p:sp>
+        <p:nvSpPr>
+          <p:cNvPr id="3" name="Content Placeholder 2">
+            <a:extLst>
+              <a:ext uri="{FF2B5EF4-FFF2-40B4-BE49-F238E27FC236}">
+                <a16:creationId xmlns:a16="http://schemas.microsoft.com/office/drawing/2014/main" id="{91787363-8C79-C6C1-5145-A1FF180C7FCC}"/>
+              </a:ext>
+            </a:extLst>
+          </p:cNvPr>
+          <p:cNvSpPr>
+            <a:spLocks noGrp="1"/>
+          </p:cNvSpPr>
+          <p:nvPr>
+            <p:ph idx="1"/>
+          </p:nvPr>
+        </p:nvSpPr>
+        <p:spPr/>
+        <p:txBody>
+          <a:bodyPr>
+            <a:normAutofit/>
+          </a:bodyPr>
+          <a:lstStyle/>
+          <a:p>
+            <a:r>
+              <a:rPr lang="en-US" dirty="0"/>
+              <a:t>Toys emerged as the leading product category, with </a:t>
+            </a:r>
+            <a:r>
+              <a:rPr lang="en-US" dirty="0" err="1"/>
+              <a:t>KidJoy</a:t>
+            </a:r>
+            <a:r>
+              <a:rPr lang="en-US" dirty="0"/>
+              <a:t> Toys 607 achieving the highest product sales, whereas Sports recorded the lowest category sales.</a:t>
+            </a:r>
+          </a:p>
+          <a:p>
+            <a:r>
+              <a:rPr lang="en-US" dirty="0"/>
+              <a:t>Geographically, Central Luzon performed best, whereas CALABARZON offers opportunities for improvement.</a:t>
+            </a:r>
+          </a:p>
+          <a:p>
+            <a:r>
+              <a:rPr lang="en-US" dirty="0"/>
+              <a:t>The Web channel generated the highest gross sales, although sales across all channels remained relatively balanced.</a:t>
+            </a:r>
+          </a:p>
+        </p:txBody>
+      </p:sp>
+    </p:spTree>
+    <p:extLst>
+      <p:ext uri="{BB962C8B-B14F-4D97-AF65-F5344CB8AC3E}">
+        <p14:creationId xmlns:p14="http://schemas.microsoft.com/office/powerpoint/2010/main" val="448462267"/>
+      </p:ext>
+    </p:extLst>
+  </p:cSld>
+  <p:clrMapOvr>
+    <a:masterClrMapping/>
+  </p:clrMapOvr>
+</p:sld>
+</file>
+
+<file path=ppt/slides/slide18.xml><?xml version="1.0" encoding="utf-8"?>
+<p:sld xmlns:a="http://schemas.openxmlformats.org/drawingml/2006/main" xmlns:r="http://schemas.openxmlformats.org/officeDocument/2006/relationships" xmlns:p="http://schemas.openxmlformats.org/presentationml/2006/main">
+  <p:cSld>
+    <p:spTree>
+      <p:nvGrpSpPr>
+        <p:cNvPr id="1" name="">
+          <a:extLst>
+            <a:ext uri="{FF2B5EF4-FFF2-40B4-BE49-F238E27FC236}">
+              <a16:creationId xmlns:a16="http://schemas.microsoft.com/office/drawing/2014/main" id="{D89B1E80-F6C2-AE68-1B2C-C3195B6F595C}"/>
+            </a:ext>
+          </a:extLst>
+        </p:cNvPr>
+        <p:cNvGrpSpPr/>
+        <p:nvPr/>
+      </p:nvGrpSpPr>
+      <p:grpSpPr>
+        <a:xfrm>
+          <a:off x="0" y="0"/>
+          <a:ext cx="0" cy="0"/>
+          <a:chOff x="0" y="0"/>
+          <a:chExt cx="0" cy="0"/>
+        </a:xfrm>
+      </p:grpSpPr>
+      <p:sp>
+        <p:nvSpPr>
+          <p:cNvPr id="2" name="Title 1">
+            <a:extLst>
+              <a:ext uri="{FF2B5EF4-FFF2-40B4-BE49-F238E27FC236}">
+                <a16:creationId xmlns:a16="http://schemas.microsoft.com/office/drawing/2014/main" id="{34BC990B-E67C-1527-E8E8-FCE039D3AF03}"/>
+              </a:ext>
+            </a:extLst>
+          </p:cNvPr>
+          <p:cNvSpPr>
+            <a:spLocks noGrp="1"/>
+          </p:cNvSpPr>
+          <p:nvPr>
+            <p:ph type="title"/>
+          </p:nvPr>
+        </p:nvSpPr>
+        <p:spPr/>
+        <p:txBody>
+          <a:bodyPr/>
+          <a:lstStyle/>
+          <a:p>
+            <a:r>
+              <a:rPr lang="en-PH" dirty="0"/>
+              <a:t>Summary and Conclusions</a:t>
+            </a:r>
+            <a:endParaRPr lang="en-US" dirty="0"/>
+          </a:p>
+        </p:txBody>
+      </p:sp>
+      <p:sp>
+        <p:nvSpPr>
+          <p:cNvPr id="3" name="Content Placeholder 2">
+            <a:extLst>
+              <a:ext uri="{FF2B5EF4-FFF2-40B4-BE49-F238E27FC236}">
+                <a16:creationId xmlns:a16="http://schemas.microsoft.com/office/drawing/2014/main" id="{7C3C3007-D56B-908F-27DD-5BA9527C4DFD}"/>
+              </a:ext>
+            </a:extLst>
+          </p:cNvPr>
+          <p:cNvSpPr>
+            <a:spLocks noGrp="1"/>
+          </p:cNvSpPr>
+          <p:nvPr>
+            <p:ph idx="1"/>
+          </p:nvPr>
+        </p:nvSpPr>
+        <p:spPr/>
+        <p:txBody>
+          <a:bodyPr>
+            <a:normAutofit/>
+          </a:bodyPr>
+          <a:lstStyle/>
+          <a:p>
+            <a:r>
+              <a:rPr lang="en-US" dirty="0"/>
+              <a:t>Most orders were valued below PHP 500, suggesting that the business primarily serves budget-conscious customers.</a:t>
+            </a:r>
+          </a:p>
+          <a:p>
+            <a:r>
+              <a:rPr lang="en-US" dirty="0"/>
+              <a:t>Monthly sales fluctuated considerably, reaching a peak in August 2025 before declining toward January 2026, whereas product returns also varied throughout the period.</a:t>
+            </a:r>
+          </a:p>
+          <a:p>
+            <a:r>
+              <a:rPr lang="en-US" dirty="0"/>
+              <a:t>Customer data shows a strong repeat-customer base, indicating potential customer loyalty and opportunities to attract new buyers.</a:t>
+            </a:r>
+          </a:p>
+        </p:txBody>
+      </p:sp>
+    </p:spTree>
+    <p:extLst>
+      <p:ext uri="{BB962C8B-B14F-4D97-AF65-F5344CB8AC3E}">
+        <p14:creationId xmlns:p14="http://schemas.microsoft.com/office/powerpoint/2010/main" val="2182352175"/>
+      </p:ext>
+    </p:extLst>
+  </p:cSld>
+  <p:clrMapOvr>
+    <a:masterClrMapping/>
+  </p:clrMapOvr>
+</p:sld>
+</file>
+
+<file path=ppt/slides/slide19.xml><?xml version="1.0" encoding="utf-8"?>
+<p:sld xmlns:a="http://schemas.openxmlformats.org/drawingml/2006/main" xmlns:r="http://schemas.openxmlformats.org/officeDocument/2006/relationships" xmlns:p="http://schemas.openxmlformats.org/presentationml/2006/main">
+  <p:cSld>
+    <p:spTree>
+      <p:nvGrpSpPr>
+        <p:cNvPr id="1" name="">
+          <a:extLst>
+            <a:ext uri="{FF2B5EF4-FFF2-40B4-BE49-F238E27FC236}">
+              <a16:creationId xmlns:a16="http://schemas.microsoft.com/office/drawing/2014/main" id="{BFD3CC3E-22E6-974D-7617-9364EF8BBE0A}"/>
+            </a:ext>
+          </a:extLst>
+        </p:cNvPr>
+        <p:cNvGrpSpPr/>
+        <p:nvPr/>
+      </p:nvGrpSpPr>
+      <p:grpSpPr>
+        <a:xfrm>
+          <a:off x="0" y="0"/>
+          <a:ext cx="0" cy="0"/>
+          <a:chOff x="0" y="0"/>
+          <a:chExt cx="0" cy="0"/>
+        </a:xfrm>
+      </p:grpSpPr>
+      <p:sp>
+        <p:nvSpPr>
+          <p:cNvPr id="2" name="Title 1">
+            <a:extLst>
+              <a:ext uri="{FF2B5EF4-FFF2-40B4-BE49-F238E27FC236}">
+                <a16:creationId xmlns:a16="http://schemas.microsoft.com/office/drawing/2014/main" id="{2FDAD622-648A-2364-7D03-78594B63F874}"/>
+              </a:ext>
+            </a:extLst>
+          </p:cNvPr>
+          <p:cNvSpPr>
+            <a:spLocks noGrp="1"/>
+          </p:cNvSpPr>
+          <p:nvPr>
+            <p:ph type="title"/>
+          </p:nvPr>
+        </p:nvSpPr>
+        <p:spPr/>
+        <p:txBody>
+          <a:bodyPr/>
+          <a:lstStyle/>
+          <a:p>
+            <a:r>
+              <a:rPr lang="en-PH" dirty="0"/>
+              <a:t>Summary and Conclusions</a:t>
+            </a:r>
+            <a:endParaRPr lang="en-US" dirty="0"/>
+          </a:p>
+        </p:txBody>
+      </p:sp>
+      <p:sp>
+        <p:nvSpPr>
+          <p:cNvPr id="3" name="Content Placeholder 2">
+            <a:extLst>
+              <a:ext uri="{FF2B5EF4-FFF2-40B4-BE49-F238E27FC236}">
+                <a16:creationId xmlns:a16="http://schemas.microsoft.com/office/drawing/2014/main" id="{3FFD342A-34CE-B5E5-334C-67632F79B2DE}"/>
+              </a:ext>
+            </a:extLst>
+          </p:cNvPr>
+          <p:cNvSpPr>
+            <a:spLocks noGrp="1"/>
+          </p:cNvSpPr>
+          <p:nvPr>
+            <p:ph idx="1"/>
+          </p:nvPr>
+        </p:nvSpPr>
+        <p:spPr/>
+        <p:txBody>
+          <a:bodyPr>
+            <a:normAutofit/>
+          </a:bodyPr>
+          <a:lstStyle/>
+          <a:p>
+            <a:r>
+              <a:rPr lang="en-US" dirty="0"/>
+              <a:t>Overall, the business demonstrates solid sales performance and a strong repeat-customer base; however, declining recent sales, fluctuating returns, and uneven category and regional performance highlight the need for targeted marketing, improved customer acquisition, effective return management, and strategies to increase average order value and sustain long-term growth.</a:t>
+            </a:r>
+          </a:p>
+        </p:txBody>
+      </p:sp>
+    </p:spTree>
+    <p:extLst>
+      <p:ext uri="{BB962C8B-B14F-4D97-AF65-F5344CB8AC3E}">
+        <p14:creationId xmlns:p14="http://schemas.microsoft.com/office/powerpoint/2010/main" val="3012059155"/>
+      </p:ext>
+    </p:extLst>
+  </p:cSld>
+  <p:clrMapOvr>
+    <a:masterClrMapping/>
+  </p:clrMapOvr>
+</p:sld>
+</file>
+
+<file path=ppt/slides/slide2.xml><?xml version="1.0" encoding="utf-8"?>
+<p:sld xmlns:a="http://schemas.openxmlformats.org/drawingml/2006/main" xmlns:r="http://schemas.openxmlformats.org/officeDocument/2006/relationships" xmlns:p="http://schemas.openxmlformats.org/presentationml/2006/main">
+  <p:cSld>
+    <p:spTree>
+      <p:nvGrpSpPr>
+        <p:cNvPr id="1" name="">
+          <a:extLst>
+            <a:ext uri="{FF2B5EF4-FFF2-40B4-BE49-F238E27FC236}">
+              <a16:creationId xmlns:a16="http://schemas.microsoft.com/office/drawing/2014/main" id="{08CF576E-7E32-453C-845D-3A06518240D9}"/>
+            </a:ext>
+          </a:extLst>
+        </p:cNvPr>
+        <p:cNvGrpSpPr/>
+        <p:nvPr/>
+      </p:nvGrpSpPr>
+      <p:grpSpPr>
+        <a:xfrm>
+          <a:off x="0" y="0"/>
+          <a:ext cx="0" cy="0"/>
+          <a:chOff x="0" y="0"/>
+          <a:chExt cx="0" cy="0"/>
+        </a:xfrm>
+      </p:grpSpPr>
+      <p:sp>
+        <p:nvSpPr>
+          <p:cNvPr id="2" name="Title 1">
+            <a:extLst>
+              <a:ext uri="{FF2B5EF4-FFF2-40B4-BE49-F238E27FC236}">
+                <a16:creationId xmlns:a16="http://schemas.microsoft.com/office/drawing/2014/main" id="{94CC8D20-6F32-6130-0DA2-91D4629CB5B7}"/>
+              </a:ext>
+            </a:extLst>
+          </p:cNvPr>
+          <p:cNvSpPr>
+            <a:spLocks noGrp="1"/>
+          </p:cNvSpPr>
+          <p:nvPr>
+            <p:ph type="title"/>
+          </p:nvPr>
+        </p:nvSpPr>
+        <p:spPr/>
+        <p:txBody>
+          <a:bodyPr/>
+          <a:lstStyle/>
+          <a:p>
+            <a:r>
+              <a:rPr lang="en-PH" dirty="0"/>
+              <a:t>Key Performance Indicators</a:t>
+            </a:r>
+            <a:endParaRPr lang="en-US" dirty="0"/>
+          </a:p>
+        </p:txBody>
+      </p:sp>
+      <p:sp>
+        <p:nvSpPr>
+          <p:cNvPr id="3" name="Content Placeholder 2">
+            <a:extLst>
+              <a:ext uri="{FF2B5EF4-FFF2-40B4-BE49-F238E27FC236}">
+                <a16:creationId xmlns:a16="http://schemas.microsoft.com/office/drawing/2014/main" id="{22C8BD1B-AF8A-1D7B-5791-9CF3EA61AF6F}"/>
+              </a:ext>
+            </a:extLst>
+          </p:cNvPr>
+          <p:cNvSpPr>
+            <a:spLocks noGrp="1"/>
+          </p:cNvSpPr>
+          <p:nvPr>
+            <p:ph idx="1"/>
+          </p:nvPr>
+        </p:nvSpPr>
+        <p:spPr/>
+        <p:txBody>
+          <a:bodyPr>
+            <a:normAutofit/>
+          </a:bodyPr>
+          <a:lstStyle/>
+          <a:p>
+            <a:r>
+              <a:rPr lang="en-US" dirty="0"/>
+              <a:t>Gross Sales: PHP 5,368,956.93</a:t>
+            </a:r>
+          </a:p>
+          <a:p>
+            <a:r>
+              <a:rPr lang="en-US" dirty="0"/>
+              <a:t>Fulfilled Orders: 11,439</a:t>
+            </a:r>
+          </a:p>
+          <a:p>
+            <a:r>
+              <a:rPr lang="en-US" dirty="0"/>
+              <a:t>Average Order Value: PHP 434.35</a:t>
+            </a:r>
+          </a:p>
+          <a:p>
+            <a:r>
+              <a:rPr lang="en-US" dirty="0"/>
+              <a:t>Top Category: Toys</a:t>
+            </a:r>
+          </a:p>
+          <a:p>
+            <a:r>
+              <a:rPr lang="en-US" dirty="0"/>
+              <a:t>Net Sales after Order Discounts: PHP 4,968,543.75</a:t>
+            </a:r>
+          </a:p>
+          <a:p>
+            <a:r>
+              <a:rPr lang="en-US" dirty="0"/>
+              <a:t>Customer Count: 22,571 Repeat vs. 4,506 New</a:t>
+            </a:r>
+          </a:p>
+          <a:p>
+            <a:endParaRPr lang="en-US" dirty="0"/>
+          </a:p>
+        </p:txBody>
+      </p:sp>
+    </p:spTree>
+    <p:extLst>
+      <p:ext uri="{BB962C8B-B14F-4D97-AF65-F5344CB8AC3E}">
+        <p14:creationId xmlns:p14="http://schemas.microsoft.com/office/powerpoint/2010/main" val="1441921333"/>
+      </p:ext>
+    </p:extLst>
+  </p:cSld>
+  <p:clrMapOvr>
+    <a:masterClrMapping/>
+  </p:clrMapOvr>
+</p:sld>
+</file>
+
+<file path=ppt/slides/slide20.xml><?xml version="1.0" encoding="utf-8"?>
+<p:sld xmlns:a="http://schemas.openxmlformats.org/drawingml/2006/main" xmlns:r="http://schemas.openxmlformats.org/officeDocument/2006/relationships" xmlns:p="http://schemas.openxmlformats.org/presentationml/2006/main">
+  <p:cSld>
+    <p:spTree>
+      <p:nvGrpSpPr>
         <p:cNvPr id="1" name=""/>
         <p:cNvGrpSpPr/>
         <p:nvPr/>
@@ -4092,7 +4545,7 @@
 </p:sld>
 </file>
 
-<file path=ppt/slides/slide18.xml><?xml version="1.0" encoding="utf-8"?>
+<file path=ppt/slides/slide21.xml><?xml version="1.0" encoding="utf-8"?>
 <p:sld xmlns:a="http://schemas.openxmlformats.org/drawingml/2006/main" xmlns:r="http://schemas.openxmlformats.org/officeDocument/2006/relationships" xmlns:p="http://schemas.openxmlformats.org/presentationml/2006/main">
   <p:cSld>
     <p:spTree>
@@ -4158,7 +4611,7 @@
 </p:sld>
 </file>
 
-<file path=ppt/slides/slide19.xml><?xml version="1.0" encoding="utf-8"?>
+<file path=ppt/slides/slide22.xml><?xml version="1.0" encoding="utf-8"?>
 <p:sld xmlns:a="http://schemas.openxmlformats.org/drawingml/2006/main" xmlns:r="http://schemas.openxmlformats.org/officeDocument/2006/relationships" xmlns:p="http://schemas.openxmlformats.org/presentationml/2006/main">
   <p:cSld>
     <p:spTree>
@@ -4218,135 +4671,7 @@
 </p:sld>
 </file>
 
-<file path=ppt/slides/slide2.xml><?xml version="1.0" encoding="utf-8"?>
-<p:sld xmlns:a="http://schemas.openxmlformats.org/drawingml/2006/main" xmlns:r="http://schemas.openxmlformats.org/officeDocument/2006/relationships" xmlns:p="http://schemas.openxmlformats.org/presentationml/2006/main">
-  <p:cSld>
-    <p:spTree>
-      <p:nvGrpSpPr>
-        <p:cNvPr id="1" name="">
-          <a:extLst>
-            <a:ext uri="{FF2B5EF4-FFF2-40B4-BE49-F238E27FC236}">
-              <a16:creationId xmlns:a16="http://schemas.microsoft.com/office/drawing/2014/main" id="{08CF576E-7E32-453C-845D-3A06518240D9}"/>
-            </a:ext>
-          </a:extLst>
-        </p:cNvPr>
-        <p:cNvGrpSpPr/>
-        <p:nvPr/>
-      </p:nvGrpSpPr>
-      <p:grpSpPr>
-        <a:xfrm>
-          <a:off x="0" y="0"/>
-          <a:ext cx="0" cy="0"/>
-          <a:chOff x="0" y="0"/>
-          <a:chExt cx="0" cy="0"/>
-        </a:xfrm>
-      </p:grpSpPr>
-      <p:sp>
-        <p:nvSpPr>
-          <p:cNvPr id="2" name="Title 1">
-            <a:extLst>
-              <a:ext uri="{FF2B5EF4-FFF2-40B4-BE49-F238E27FC236}">
-                <a16:creationId xmlns:a16="http://schemas.microsoft.com/office/drawing/2014/main" id="{94CC8D20-6F32-6130-0DA2-91D4629CB5B7}"/>
-              </a:ext>
-            </a:extLst>
-          </p:cNvPr>
-          <p:cNvSpPr>
-            <a:spLocks noGrp="1"/>
-          </p:cNvSpPr>
-          <p:nvPr>
-            <p:ph type="title"/>
-          </p:nvPr>
-        </p:nvSpPr>
-        <p:spPr/>
-        <p:txBody>
-          <a:bodyPr/>
-          <a:lstStyle/>
-          <a:p>
-            <a:r>
-              <a:rPr lang="en-PH" dirty="0"/>
-              <a:t>Key Performance Indicators</a:t>
-            </a:r>
-            <a:endParaRPr lang="en-US" dirty="0"/>
-          </a:p>
-        </p:txBody>
-      </p:sp>
-      <p:sp>
-        <p:nvSpPr>
-          <p:cNvPr id="3" name="Content Placeholder 2">
-            <a:extLst>
-              <a:ext uri="{FF2B5EF4-FFF2-40B4-BE49-F238E27FC236}">
-                <a16:creationId xmlns:a16="http://schemas.microsoft.com/office/drawing/2014/main" id="{22C8BD1B-AF8A-1D7B-5791-9CF3EA61AF6F}"/>
-              </a:ext>
-            </a:extLst>
-          </p:cNvPr>
-          <p:cNvSpPr>
-            <a:spLocks noGrp="1"/>
-          </p:cNvSpPr>
-          <p:nvPr>
-            <p:ph idx="1"/>
-          </p:nvPr>
-        </p:nvSpPr>
-        <p:spPr/>
-        <p:txBody>
-          <a:bodyPr>
-            <a:normAutofit/>
-          </a:bodyPr>
-          <a:lstStyle/>
-          <a:p>
-            <a:r>
-              <a:rPr lang="en-US" dirty="0"/>
-              <a:t>Gross Sales: PHP 5,368,956.93</a:t>
-            </a:r>
-          </a:p>
-          <a:p>
-            <a:r>
-              <a:rPr lang="en-US" dirty="0"/>
-              <a:t>Fulfilled Orders: 11,439</a:t>
-            </a:r>
-          </a:p>
-          <a:p>
-            <a:r>
-              <a:rPr lang="en-US" dirty="0"/>
-              <a:t>Average Order Value: PHP 434.35</a:t>
-            </a:r>
-          </a:p>
-          <a:p>
-            <a:r>
-              <a:rPr lang="en-US" dirty="0"/>
-              <a:t>Top Category: Toys</a:t>
-            </a:r>
-          </a:p>
-          <a:p>
-            <a:r>
-              <a:rPr lang="en-US" dirty="0"/>
-              <a:t>Net Sales after Order Discounts: PHP 4,968,543.75</a:t>
-            </a:r>
-          </a:p>
-          <a:p>
-            <a:r>
-              <a:rPr lang="en-US" dirty="0"/>
-              <a:t>Customer Count: 22,571 Repeat vs. 4,506 New</a:t>
-            </a:r>
-          </a:p>
-          <a:p>
-            <a:endParaRPr lang="en-US" dirty="0"/>
-          </a:p>
-        </p:txBody>
-      </p:sp>
-    </p:spTree>
-    <p:extLst>
-      <p:ext uri="{BB962C8B-B14F-4D97-AF65-F5344CB8AC3E}">
-        <p14:creationId xmlns:p14="http://schemas.microsoft.com/office/powerpoint/2010/main" val="1441921333"/>
-      </p:ext>
-    </p:extLst>
-  </p:cSld>
-  <p:clrMapOvr>
-    <a:masterClrMapping/>
-  </p:clrMapOvr>
-</p:sld>
-</file>
-
-<file path=ppt/slides/slide20.xml><?xml version="1.0" encoding="utf-8"?>
+<file path=ppt/slides/slide23.xml><?xml version="1.0" encoding="utf-8"?>
 <p:sld xmlns:a="http://schemas.openxmlformats.org/drawingml/2006/main" xmlns:r="http://schemas.openxmlformats.org/officeDocument/2006/relationships" xmlns:p="http://schemas.openxmlformats.org/presentationml/2006/main">
   <p:cSld>
     <p:spTree>
@@ -4503,7 +4828,7 @@
 </p:sld>
 </file>
 
-<file path=ppt/slides/slide21.xml><?xml version="1.0" encoding="utf-8"?>
+<file path=ppt/slides/slide24.xml><?xml version="1.0" encoding="utf-8"?>
 <p:sld xmlns:a="http://schemas.openxmlformats.org/drawingml/2006/main" xmlns:r="http://schemas.openxmlformats.org/officeDocument/2006/relationships" xmlns:p="http://schemas.openxmlformats.org/presentationml/2006/main">
   <p:cSld>
     <p:spTree>
@@ -4622,7 +4947,7 @@
 </p:sld>
 </file>
 
-<file path=ppt/slides/slide22.xml><?xml version="1.0" encoding="utf-8"?>
+<file path=ppt/slides/slide25.xml><?xml version="1.0" encoding="utf-8"?>
 <p:sld xmlns:a="http://schemas.openxmlformats.org/drawingml/2006/main" xmlns:r="http://schemas.openxmlformats.org/officeDocument/2006/relationships" xmlns:p="http://schemas.openxmlformats.org/presentationml/2006/main">
   <p:cSld>
     <p:spTree>
@@ -4759,7 +5084,7 @@
 </p:sld>
 </file>
 
-<file path=ppt/slides/slide23.xml><?xml version="1.0" encoding="utf-8"?>
+<file path=ppt/slides/slide26.xml><?xml version="1.0" encoding="utf-8"?>
 <p:sld xmlns:a="http://schemas.openxmlformats.org/drawingml/2006/main" xmlns:r="http://schemas.openxmlformats.org/officeDocument/2006/relationships" xmlns:p="http://schemas.openxmlformats.org/presentationml/2006/main">
   <p:cSld>
     <p:spTree>
@@ -4926,7 +5251,7 @@
 </p:sld>
 </file>
 
-<file path=ppt/slides/slide24.xml><?xml version="1.0" encoding="utf-8"?>
+<file path=ppt/slides/slide27.xml><?xml version="1.0" encoding="utf-8"?>
 <p:sld xmlns:a="http://schemas.openxmlformats.org/drawingml/2006/main" xmlns:r="http://schemas.openxmlformats.org/officeDocument/2006/relationships" xmlns:p="http://schemas.openxmlformats.org/presentationml/2006/main">
   <p:cSld>
     <p:spTree>
@@ -5057,7 +5382,7 @@
 </p:sld>
 </file>
 
-<file path=ppt/slides/slide25.xml><?xml version="1.0" encoding="utf-8"?>
+<file path=ppt/slides/slide28.xml><?xml version="1.0" encoding="utf-8"?>
 <p:sld xmlns:a="http://schemas.openxmlformats.org/drawingml/2006/main" xmlns:r="http://schemas.openxmlformats.org/officeDocument/2006/relationships" xmlns:p="http://schemas.openxmlformats.org/presentationml/2006/main">
   <p:cSld>
     <p:spTree>

</xml_diff>